<commit_message>
Complete registration ML via winodw service  (NSSM)
</commit_message>
<xml_diff>
--- a/handoff/DeviceIdentifierProgress.pptx
+++ b/handoff/DeviceIdentifierProgress.pptx
@@ -7788,18 +7788,15 @@
       </p:grpSpPr>
       <p:pic>
         <p:nvPicPr>
-          <p:cNvPr id="2" name="Picture 1">
+          <p:cNvPr id="6" name="Picture 5">
             <a:extLst>
               <a:ext uri="{FF2B5EF4-FFF2-40B4-BE49-F238E27FC236}">
-                <a16:creationId xmlns:a16="http://schemas.microsoft.com/office/drawing/2014/main" id="{3B2328C8-9BCF-E4E4-591C-F0D9C2A74396}"/>
-              </a:ext>
-              <a:ext uri="{C183D7F6-B498-43B3-948B-1728B52AA6E4}">
-                <adec:decorative xmlns:adec="http://schemas.microsoft.com/office/drawing/2017/decorative" val="1"/>
+                <a16:creationId xmlns:a16="http://schemas.microsoft.com/office/drawing/2014/main" id="{9AF8E737-0264-407F-B960-B302C0A7065D}"/>
               </a:ext>
             </a:extLst>
           </p:cNvPr>
           <p:cNvPicPr>
-            <a:picLocks noGrp="1" noRot="1" noChangeAspect="1" noMove="1" noResize="1" noEditPoints="1" noAdjustHandles="1" noChangeArrowheads="1" noChangeShapeType="1" noCrop="1"/>
+            <a:picLocks noChangeAspect="1"/>
           </p:cNvPicPr>
           <p:nvPr/>
         </p:nvPicPr>
@@ -7811,364 +7808,14 @@
         </p:blipFill>
         <p:spPr>
           <a:xfrm>
-            <a:off x="2844741" y="321048"/>
-            <a:ext cx="7960562" cy="5713880"/>
+            <a:off x="1464733" y="651660"/>
+            <a:ext cx="9635334" cy="5393539"/>
           </a:xfrm>
           <a:prstGeom prst="rect">
             <a:avLst/>
           </a:prstGeom>
         </p:spPr>
       </p:pic>
-      <p:sp>
-        <p:nvSpPr>
-          <p:cNvPr id="5" name="Rectangle 4">
-            <a:extLst>
-              <a:ext uri="{FF2B5EF4-FFF2-40B4-BE49-F238E27FC236}">
-                <a16:creationId xmlns:a16="http://schemas.microsoft.com/office/drawing/2014/main" id="{024E87D5-9CF2-B963-723E-B5B79C4EE249}"/>
-              </a:ext>
-            </a:extLst>
-          </p:cNvPr>
-          <p:cNvSpPr>
-            <a:spLocks noGrp="1" noRot="1" noMove="1" noResize="1" noEditPoints="1" noAdjustHandles="1" noChangeArrowheads="1" noChangeShapeType="1"/>
-          </p:cNvSpPr>
-          <p:nvPr/>
-        </p:nvSpPr>
-        <p:spPr>
-          <a:xfrm>
-            <a:off x="7428812" y="4056596"/>
-            <a:ext cx="3836894" cy="1687046"/>
-          </a:xfrm>
-          <a:prstGeom prst="rect">
-            <a:avLst/>
-          </a:prstGeom>
-          <a:solidFill>
-            <a:schemeClr val="bg1"/>
-          </a:solidFill>
-          <a:ln>
-            <a:noFill/>
-          </a:ln>
-        </p:spPr>
-        <p:style>
-          <a:lnRef idx="2">
-            <a:schemeClr val="accent1">
-              <a:shade val="15000"/>
-            </a:schemeClr>
-          </a:lnRef>
-          <a:fillRef idx="1">
-            <a:schemeClr val="accent1"/>
-          </a:fillRef>
-          <a:effectRef idx="0">
-            <a:schemeClr val="accent1"/>
-          </a:effectRef>
-          <a:fontRef idx="minor">
-            <a:schemeClr val="lt1"/>
-          </a:fontRef>
-        </p:style>
-        <p:txBody>
-          <a:bodyPr rtlCol="0" anchor="ctr"/>
-          <a:lstStyle/>
-          <a:p>
-            <a:pPr algn="ctr"/>
-            <a:endParaRPr lang="en-MY"/>
-          </a:p>
-        </p:txBody>
-      </p:sp>
-      <p:sp>
-        <p:nvSpPr>
-          <p:cNvPr id="4" name="Rectangle 3">
-            <a:extLst>
-              <a:ext uri="{FF2B5EF4-FFF2-40B4-BE49-F238E27FC236}">
-                <a16:creationId xmlns:a16="http://schemas.microsoft.com/office/drawing/2014/main" id="{FEBF4457-938C-1395-B6DD-5D0BF8AD875F}"/>
-              </a:ext>
-            </a:extLst>
-          </p:cNvPr>
-          <p:cNvSpPr/>
-          <p:nvPr/>
-        </p:nvSpPr>
-        <p:spPr>
-          <a:xfrm>
-            <a:off x="3788876" y="3934878"/>
-            <a:ext cx="1294111" cy="338554"/>
-          </a:xfrm>
-          <a:prstGeom prst="rect">
-            <a:avLst/>
-          </a:prstGeom>
-          <a:solidFill>
-            <a:schemeClr val="bg1"/>
-          </a:solidFill>
-        </p:spPr>
-        <p:txBody>
-          <a:bodyPr wrap="square" lIns="91440" tIns="45720" rIns="91440" bIns="45720">
-            <a:spAutoFit/>
-          </a:bodyPr>
-          <a:lstStyle/>
-          <a:p>
-            <a:pPr algn="ctr"/>
-            <a:r>
-              <a:rPr lang="en-US" sz="1600" dirty="0">
-                <a:ln w="0"/>
-                <a:effectLst>
-                  <a:outerShdw blurRad="38100" dist="19050" dir="2700000" algn="tl" rotWithShape="0">
-                    <a:schemeClr val="dk1">
-                      <a:alpha val="40000"/>
-                    </a:schemeClr>
-                  </a:outerShdw>
-                </a:effectLst>
-              </a:rPr>
-              <a:t>ML service</a:t>
-            </a:r>
-            <a:endParaRPr lang="en-US" sz="1600" b="0" cap="none" spc="0" dirty="0">
-              <a:ln w="0"/>
-              <a:solidFill>
-                <a:schemeClr val="tx1"/>
-              </a:solidFill>
-              <a:effectLst>
-                <a:outerShdw blurRad="38100" dist="19050" dir="2700000" algn="tl" rotWithShape="0">
-                  <a:schemeClr val="dk1">
-                    <a:alpha val="40000"/>
-                  </a:schemeClr>
-                </a:outerShdw>
-              </a:effectLst>
-            </a:endParaRPr>
-          </a:p>
-        </p:txBody>
-      </p:sp>
-      <p:sp>
-        <p:nvSpPr>
-          <p:cNvPr id="7" name="Rectangle 6">
-            <a:extLst>
-              <a:ext uri="{FF2B5EF4-FFF2-40B4-BE49-F238E27FC236}">
-                <a16:creationId xmlns:a16="http://schemas.microsoft.com/office/drawing/2014/main" id="{CB1DCC46-DF47-2BDC-F6A7-47F902B0FF08}"/>
-              </a:ext>
-            </a:extLst>
-          </p:cNvPr>
-          <p:cNvSpPr/>
-          <p:nvPr/>
-        </p:nvSpPr>
-        <p:spPr>
-          <a:xfrm>
-            <a:off x="2961233" y="1577787"/>
-            <a:ext cx="4551192" cy="4195483"/>
-          </a:xfrm>
-          <a:prstGeom prst="rect">
-            <a:avLst/>
-          </a:prstGeom>
-          <a:noFill/>
-        </p:spPr>
-        <p:style>
-          <a:lnRef idx="2">
-            <a:schemeClr val="accent1">
-              <a:shade val="15000"/>
-            </a:schemeClr>
-          </a:lnRef>
-          <a:fillRef idx="1">
-            <a:schemeClr val="accent1"/>
-          </a:fillRef>
-          <a:effectRef idx="0">
-            <a:schemeClr val="accent1"/>
-          </a:effectRef>
-          <a:fontRef idx="minor">
-            <a:schemeClr val="lt1"/>
-          </a:fontRef>
-        </p:style>
-        <p:txBody>
-          <a:bodyPr rtlCol="0" anchor="ctr"/>
-          <a:lstStyle/>
-          <a:p>
-            <a:pPr algn="ctr"/>
-            <a:endParaRPr lang="en-MY"/>
-          </a:p>
-        </p:txBody>
-      </p:sp>
-      <p:sp>
-        <p:nvSpPr>
-          <p:cNvPr id="9" name="Rectangle 8">
-            <a:extLst>
-              <a:ext uri="{FF2B5EF4-FFF2-40B4-BE49-F238E27FC236}">
-                <a16:creationId xmlns:a16="http://schemas.microsoft.com/office/drawing/2014/main" id="{63F89C72-AC29-D555-2211-02C23C26692D}"/>
-              </a:ext>
-            </a:extLst>
-          </p:cNvPr>
-          <p:cNvSpPr/>
-          <p:nvPr/>
-        </p:nvSpPr>
-        <p:spPr>
-          <a:xfrm>
-            <a:off x="3797842" y="1750597"/>
-            <a:ext cx="1294111" cy="338554"/>
-          </a:xfrm>
-          <a:prstGeom prst="rect">
-            <a:avLst/>
-          </a:prstGeom>
-          <a:solidFill>
-            <a:schemeClr val="bg1"/>
-          </a:solidFill>
-        </p:spPr>
-        <p:txBody>
-          <a:bodyPr wrap="square" lIns="91440" tIns="45720" rIns="91440" bIns="45720">
-            <a:spAutoFit/>
-          </a:bodyPr>
-          <a:lstStyle/>
-          <a:p>
-            <a:pPr algn="ctr"/>
-            <a:r>
-              <a:rPr lang="en-US" sz="1600" dirty="0">
-                <a:ln w="0"/>
-                <a:effectLst>
-                  <a:outerShdw blurRad="38100" dist="19050" dir="2700000" algn="tl" rotWithShape="0">
-                    <a:schemeClr val="dk1">
-                      <a:alpha val="40000"/>
-                    </a:schemeClr>
-                  </a:outerShdw>
-                </a:effectLst>
-              </a:rPr>
-              <a:t>API service</a:t>
-            </a:r>
-            <a:endParaRPr lang="en-US" sz="1600" b="0" cap="none" spc="0" dirty="0">
-              <a:ln w="0"/>
-              <a:solidFill>
-                <a:schemeClr val="tx1"/>
-              </a:solidFill>
-              <a:effectLst>
-                <a:outerShdw blurRad="38100" dist="19050" dir="2700000" algn="tl" rotWithShape="0">
-                  <a:schemeClr val="dk1">
-                    <a:alpha val="40000"/>
-                  </a:schemeClr>
-                </a:outerShdw>
-              </a:effectLst>
-            </a:endParaRPr>
-          </a:p>
-        </p:txBody>
-      </p:sp>
-      <p:sp>
-        <p:nvSpPr>
-          <p:cNvPr id="12" name="Rectangle 11">
-            <a:extLst>
-              <a:ext uri="{FF2B5EF4-FFF2-40B4-BE49-F238E27FC236}">
-                <a16:creationId xmlns:a16="http://schemas.microsoft.com/office/drawing/2014/main" id="{2E3A9353-9505-04E4-3412-00C870BE1CE6}"/>
-              </a:ext>
-            </a:extLst>
-          </p:cNvPr>
-          <p:cNvSpPr/>
-          <p:nvPr/>
-        </p:nvSpPr>
-        <p:spPr>
-          <a:xfrm>
-            <a:off x="7763435" y="1325096"/>
-            <a:ext cx="2402541" cy="2591852"/>
-          </a:xfrm>
-          <a:prstGeom prst="rect">
-            <a:avLst/>
-          </a:prstGeom>
-          <a:noFill/>
-        </p:spPr>
-        <p:style>
-          <a:lnRef idx="2">
-            <a:schemeClr val="accent1">
-              <a:shade val="15000"/>
-            </a:schemeClr>
-          </a:lnRef>
-          <a:fillRef idx="1">
-            <a:schemeClr val="accent1"/>
-          </a:fillRef>
-          <a:effectRef idx="0">
-            <a:schemeClr val="accent1"/>
-          </a:effectRef>
-          <a:fontRef idx="minor">
-            <a:schemeClr val="lt1"/>
-          </a:fontRef>
-        </p:style>
-        <p:txBody>
-          <a:bodyPr rtlCol="0" anchor="ctr"/>
-          <a:lstStyle/>
-          <a:p>
-            <a:pPr algn="ctr"/>
-            <a:endParaRPr lang="en-MY"/>
-          </a:p>
-        </p:txBody>
-      </p:sp>
-      <p:sp>
-        <p:nvSpPr>
-          <p:cNvPr id="10" name="TextBox 9">
-            <a:extLst>
-              <a:ext uri="{FF2B5EF4-FFF2-40B4-BE49-F238E27FC236}">
-                <a16:creationId xmlns:a16="http://schemas.microsoft.com/office/drawing/2014/main" id="{204E8AF6-F6C9-6520-F632-C0555A5E13AB}"/>
-              </a:ext>
-            </a:extLst>
-          </p:cNvPr>
-          <p:cNvSpPr txBox="1"/>
-          <p:nvPr/>
-        </p:nvSpPr>
-        <p:spPr>
-          <a:xfrm>
-            <a:off x="8127724" y="1063438"/>
-            <a:ext cx="1650581" cy="369332"/>
-          </a:xfrm>
-          <a:prstGeom prst="rect">
-            <a:avLst/>
-          </a:prstGeom>
-          <a:solidFill>
-            <a:schemeClr val="accent1">
-              <a:lumMod val="20000"/>
-              <a:lumOff val="80000"/>
-            </a:schemeClr>
-          </a:solidFill>
-        </p:spPr>
-        <p:txBody>
-          <a:bodyPr wrap="none" rtlCol="0">
-            <a:spAutoFit/>
-          </a:bodyPr>
-          <a:lstStyle/>
-          <a:p>
-            <a:pPr algn="ctr"/>
-            <a:r>
-              <a:rPr lang="en-MY" b="1" dirty="0"/>
-              <a:t>Neptune Server</a:t>
-            </a:r>
-          </a:p>
-        </p:txBody>
-      </p:sp>
-      <p:sp>
-        <p:nvSpPr>
-          <p:cNvPr id="14" name="TextBox 13">
-            <a:extLst>
-              <a:ext uri="{FF2B5EF4-FFF2-40B4-BE49-F238E27FC236}">
-                <a16:creationId xmlns:a16="http://schemas.microsoft.com/office/drawing/2014/main" id="{4BEA2E67-67FC-8DC1-B6A8-300FA5BA819C}"/>
-              </a:ext>
-            </a:extLst>
-          </p:cNvPr>
-          <p:cNvSpPr txBox="1"/>
-          <p:nvPr/>
-        </p:nvSpPr>
-        <p:spPr>
-          <a:xfrm>
-            <a:off x="2682637" y="1294860"/>
-            <a:ext cx="1815690" cy="369332"/>
-          </a:xfrm>
-          <a:prstGeom prst="rect">
-            <a:avLst/>
-          </a:prstGeom>
-          <a:solidFill>
-            <a:schemeClr val="accent1">
-              <a:lumMod val="20000"/>
-              <a:lumOff val="80000"/>
-            </a:schemeClr>
-          </a:solidFill>
-        </p:spPr>
-        <p:txBody>
-          <a:bodyPr wrap="none" rtlCol="0">
-            <a:spAutoFit/>
-          </a:bodyPr>
-          <a:lstStyle/>
-          <a:p>
-            <a:pPr algn="ctr"/>
-            <a:r>
-              <a:rPr lang="en-MY" b="1" dirty="0"/>
-              <a:t>SSSBPD01 Server</a:t>
-            </a:r>
-          </a:p>
-        </p:txBody>
-      </p:sp>
     </p:spTree>
     <p:extLst>
       <p:ext uri="{BB962C8B-B14F-4D97-AF65-F5344CB8AC3E}">

</xml_diff>